<commit_message>
Address instructor midterm issues
</commit_message>
<xml_diff>
--- a/midterm.pptx
+++ b/midterm.pptx
@@ -6743,20 +6743,33 @@
                 <a:cs typeface="Times New Roman"/>
               </a:defRPr>
             </a:pPr>
-            <a:r>
-              <a:rPr sz="1575" b="0">
-                <a:solidFill>
-                  <a:srgbClr val="5F686F"/>
-                </a:solidFill>
-                <a:latin typeface="Times New Roman"/>
-                <a:ea typeface="Times New Roman"/>
-                <a:cs typeface="Times New Roman"/>
-              </a:rPr>
-              <a:t>Insert prototype screenshot here</a:t>
-            </a:r>
           </a:p>
         </p:txBody>
       </p:sp>
+      <p:pic xmlns:a="http://schemas.openxmlformats.org/drawingml/2006/main" xmlns:r="http://schemas.openxmlformats.org/officeDocument/2006/relationships">
+        <p:nvPicPr>
+          <p:cNvPr id="15" name="Picture 14" descr="prototype-screenshot.png"/>
+          <p:cNvPicPr>
+            <a:picLocks noChangeAspect="1"/>
+          </p:cNvPicPr>
+          <p:nvPr/>
+        </p:nvPicPr>
+        <p:blipFill>
+          <a:blip r:embed="rId3"/>
+          <a:stretch>
+            <a:fillRect/>
+          </a:stretch>
+        </p:blipFill>
+        <p:spPr>
+          <a:xfrm>
+            <a:off x="7597902" y="1787652"/>
+            <a:ext cx="3282696" cy="2425446"/>
+          </a:xfrm>
+          <a:prstGeom prst="rect">
+            <a:avLst/>
+          </a:prstGeom>
+        </p:spPr>
+      </p:pic>
     </p:spTree>
     <p:extLst>
       <p:ext uri="{BB962C8B-B14F-4D97-AF65-F5344CB8AC3E}">

</xml_diff>